<commit_message>
Baseline RAG adapter suite, parser microservices, and two-phase processing
確定スタック(OCI Enterprise AI / OCI Generative AI Cohere / Oracle 26ai)に沿って
作業ツリーに未コミットだった累積実装をベースライン化する。

- parser/chunking/retrieval/grounding/generation/guardrail/vector-index/
  evaluation/graph/agentic の各アダプターと設定 API・設定画面
- parser 層をマイクロサービス委譲へ再編(packages/rag_parser_core 共有 core +
  services/parsers/* の docling/marker/unstructured/mineru/dots_ocr 各サービス +
  backend/app/clients/parser_service の HTTP runner 注入)
- 2 段階ファイル処理(parse→人手プレビュー確認→index)と review gate
- KB 単位アダプター上書き、診断/監査/観測の拡充
- frontend 設定画面群と e2e、評価 fixtures

注: 出自は作業ツリーの累積変更。internal の health check は ruff 緑・pytest collect 正常。

Co-Authored-By: Claude Opus 4.8 <noreply@anthropic.com>
</commit_message>
<xml_diff>
--- a/rag/evaluation/file-processing-fixtures/product-brief-ja.pptx
+++ b/rag/evaluation/file-processing-fixtures/product-brief-ja.pptx
@@ -1,14 +1,35 @@
 
 <file path=ppt/presentation.xml><?xml version="1.0" encoding="utf-8"?>
-<p:presentation xmlns:p="http://schemas.openxmlformats.org/presentationml/2006/main"/>
+<p:presentation xmlns:p="http://schemas.openxmlformats.org/presentationml/2006/main" xmlns:a="http://schemas.openxmlformats.org/drawingml/2006/main" xmlns:r="http://schemas.openxmlformats.org/officeDocument/2006/relationships">
+  <p:sldIdLst>
+    <p:sldId id="256" r:id="rId1"/>
+    <p:sldId id="257" r:id="rId2"/>
+  </p:sldIdLst>
+  <p:sldSz cx="9144000" cy="5143500" type="screen16x9"/>
+  <p:notesSz cx="6858000" cy="9144000"/>
+</p:presentation>
 </file>
 
 <file path=ppt/slides/slide1.xml><?xml version="1.0" encoding="utf-8"?>
 <p:sld xmlns:p="http://schemas.openxmlformats.org/presentationml/2006/main" xmlns:a="http://schemas.openxmlformats.org/drawingml/2006/main">
   <p:cSld>
     <p:spTree>
+      <p:nvGrpSpPr>
+        <p:cNvPr id="1" name=""/>
+        <p:cNvGrpSpPr/>
+        <p:nvPr/>
+      </p:nvGrpSpPr>
+      <p:grpSpPr/>
       <p:sp>
+        <p:nvSpPr>
+          <p:cNvPr id="2" name="Title"/>
+          <p:cNvSpPr txBox="1"/>
+          <p:nvPr/>
+        </p:nvSpPr>
+        <p:spPr/>
         <p:txBody>
+          <a:bodyPr/>
+          <a:lstStyle/>
           <a:p>
             <a:r>
               <a:t>製品概要: RAG取込</a:t>
@@ -25,8 +46,22 @@
 <p:sld xmlns:p="http://schemas.openxmlformats.org/presentationml/2006/main" xmlns:a="http://schemas.openxmlformats.org/drawingml/2006/main">
   <p:cSld>
     <p:spTree>
+      <p:nvGrpSpPr>
+        <p:cNvPr id="1" name=""/>
+        <p:cNvGrpSpPr/>
+        <p:nvPr/>
+      </p:nvGrpSpPr>
+      <p:grpSpPr/>
       <p:sp>
+        <p:nvSpPr>
+          <p:cNvPr id="2" name="Title"/>
+          <p:cNvSpPr txBox="1"/>
+          <p:nvPr/>
+        </p:nvSpPr>
+        <p:spPr/>
         <p:txBody>
+          <a:bodyPr/>
+          <a:lstStyle/>
           <a:p>
             <a:r>
               <a:t>検索品質: 引用とページ番号を保持</a:t>

</xml_diff>